<commit_message>
Update BFF architecture presentation with content corrections
Refreshed slide deck (Martin's edits). Binary diff only — no
structural changes to the talk's narrative arc.

Co-Authored-By: Claude Opus 4.7 (1M context) <noreply@anthropic.com>
</commit_message>
<xml_diff>
--- a/docs/BFF_Demo_Praesentation.pptx
+++ b/docs/BFF_Demo_Praesentation.pptx
@@ -20,7 +20,7 @@
     <p:sldId id="262" r:id="rId11"/>
     <p:sldId id="265" r:id="rId12"/>
     <p:sldId id="266" r:id="rId13"/>
-    <p:sldId id="263" r:id="rId14"/>
+    <p:sldId id="267" r:id="rId14"/>
     <p:sldId id="264" r:id="rId15"/>
   </p:sldIdLst>
   <p:sldSz cx="12192000" cy="6858000"/>
@@ -253,7 +253,7 @@
           <a:p>
             <a:fld id="{E611DA85-BD4C-4CE5-8DCE-74C0F2473EEC}" type="datetimeFigureOut">
               <a:rPr lang="en-US" smtClean="0"/>
-              <a:t>4/24/2026</a:t>
+              <a:t>4/25/2026</a:t>
             </a:fld>
             <a:endParaRPr lang="en-US" dirty="0"/>
           </a:p>
@@ -451,7 +451,7 @@
             <a:fld id="{89D530DC-3D95-4EFE-803D-905449110749}" type="datetimeFigureOut">
               <a:rPr lang="de-DE" smtClean="0"/>
               <a:pPr/>
-              <a:t>24.04.2026</a:t>
+              <a:t>25.04.2026</a:t>
             </a:fld>
             <a:endParaRPr lang="de-DE" dirty="0"/>
           </a:p>
@@ -908,6 +908,111 @@
 </p:notesMaster>
 </file>
 
+<file path=ppt/notesSlides/notesSlide1.xml><?xml version="1.0" encoding="utf-8"?>
+<p:notes xmlns:a="http://schemas.openxmlformats.org/drawingml/2006/main" xmlns:r="http://schemas.openxmlformats.org/officeDocument/2006/relationships" xmlns:p="http://schemas.openxmlformats.org/presentationml/2006/main">
+  <p:cSld>
+    <p:spTree>
+      <p:nvGrpSpPr>
+        <p:cNvPr id="1" name=""/>
+        <p:cNvGrpSpPr/>
+        <p:nvPr/>
+      </p:nvGrpSpPr>
+      <p:grpSpPr>
+        <a:xfrm>
+          <a:off x="0" y="0"/>
+          <a:ext cx="0" cy="0"/>
+          <a:chOff x="0" y="0"/>
+          <a:chExt cx="0" cy="0"/>
+        </a:xfrm>
+      </p:grpSpPr>
+      <p:sp>
+        <p:nvSpPr>
+          <p:cNvPr id="2" name="Slide Image Placeholder 1"/>
+          <p:cNvSpPr>
+            <a:spLocks noGrp="1" noRot="1" noChangeAspect="1"/>
+          </p:cNvSpPr>
+          <p:nvPr>
+            <p:ph type="sldImg" idx="2"/>
+          </p:nvPr>
+        </p:nvSpPr>
+        <p:spPr/>
+      </p:sp>
+      <p:sp>
+        <p:nvSpPr>
+          <p:cNvPr id="3" name="Notes Placeholder 2"/>
+          <p:cNvSpPr>
+            <a:spLocks noGrp="1"/>
+          </p:cNvSpPr>
+          <p:nvPr>
+            <p:ph type="body" sz="quarter" idx="3"/>
+          </p:nvPr>
+        </p:nvSpPr>
+        <p:spPr/>
+        <p:txBody>
+          <a:bodyPr/>
+          <a:lstStyle/>
+          <a:p>
+            <a:r>
+              <a:t>– Setup: zwei Frontends, eine Service-Landschaft</a:t>
+            </a:r>
+          </a:p>
+          <a:p>
+            <a:r>
+              <a:t>– Zwei Szenarien: Read (Aggregation) + Write (Saga mit Kompensation)</a:t>
+            </a:r>
+          </a:p>
+          <a:p>
+            <a:r>
+              <a:t>– 5 Beobachtungspunkte, die ich aktiv ansage:</a:t>
+            </a:r>
+          </a:p>
+          <a:p>
+            <a:r>
+              <a:t>– 1. Network-Tab — viele Calls vs. ein Call</a:t>
+            </a:r>
+          </a:p>
+          <a:p>
+            <a:r>
+              <a:t>– 2. Token — im Storage sichtbar vs. nur Session-Cookie</a:t>
+            </a:r>
+          </a:p>
+          <a:p>
+            <a:r>
+              <a:t>– 3. TS-Integrationslogik — im Client vs. schlank</a:t>
+            </a:r>
+          </a:p>
+          <a:p>
+            <a:r>
+              <a:t>– 4. Fehlerfall-Write — Client-Saga vs. Backend-Saga</a:t>
+            </a:r>
+          </a:p>
+          <a:p>
+            <a:r>
+              <a:t>– 5. Änderungswirkung — Gedankenspiel: was müsste sich im Frontend ändern?</a:t>
+            </a:r>
+          </a:p>
+        </p:txBody>
+      </p:sp>
+      <p:sp>
+        <p:nvSpPr>
+          <p:cNvPr id="4" name="Slide Number Placeholder 3"/>
+          <p:cNvSpPr>
+            <a:spLocks noGrp="1"/>
+          </p:cNvSpPr>
+          <p:nvPr>
+            <p:ph type="sldNum" sz="quarter" idx="5"/>
+          </p:nvPr>
+        </p:nvSpPr>
+        <p:spPr/>
+      </p:sp>
+    </p:spTree>
+  </p:cSld>
+  <p:clrMapOvr>
+    <a:masterClrMapping/>
+  </p:clrMapOvr>
+</p:notes>
+</file>
+
 <file path=ppt/slideLayouts/slideLayout1.xml><?xml version="1.0" encoding="utf-8"?>
 <p:sldLayout xmlns:a="http://schemas.openxmlformats.org/drawingml/2006/main" xmlns:r="http://schemas.openxmlformats.org/officeDocument/2006/relationships" xmlns:p="http://schemas.openxmlformats.org/presentationml/2006/main" showMasterSp="0" preserve="1" userDrawn="1">
   <p:cSld name="Title 1">
@@ -967,7 +1072,7 @@
           <a:graphicData uri="http://schemas.openxmlformats.org/presentationml/2006/ole">
             <mc:AlternateContent xmlns:mc="http://schemas.openxmlformats.org/markup-compatibility/2006">
               <mc:Choice xmlns:v="urn:schemas-microsoft-com:vml" Requires="v">
-                <p:oleObj spid="_x0000_s2052" name="think-cell Slide" r:id="rId4" imgW="347" imgH="348" progId="TCLayout.ActiveDocument.1">
+                <p:oleObj spid="_x0000_s2053" name="think-cell Slide" r:id="rId4" imgW="347" imgH="348" progId="TCLayout.ActiveDocument.1">
                   <p:embed/>
                 </p:oleObj>
               </mc:Choice>
@@ -1343,7 +1448,7 @@
           <a:graphicData uri="http://schemas.openxmlformats.org/presentationml/2006/ole">
             <mc:AlternateContent xmlns:mc="http://schemas.openxmlformats.org/markup-compatibility/2006">
               <mc:Choice xmlns:v="urn:schemas-microsoft-com:vml" Requires="v">
-                <p:oleObj spid="_x0000_s11268" name="think-cell Slide" r:id="rId4" imgW="347" imgH="348" progId="TCLayout.ActiveDocument.1">
+                <p:oleObj spid="_x0000_s11269" name="think-cell Slide" r:id="rId4" imgW="347" imgH="348" progId="TCLayout.ActiveDocument.1">
                   <p:embed/>
                 </p:oleObj>
               </mc:Choice>
@@ -1934,7 +2039,7 @@
           <a:p>
             <a:fld id="{0855D730-6933-45F2-B321-12D08602E76D}" type="datetime4">
               <a:rPr lang="en-US" noProof="0" smtClean="0"/>
-              <a:t>April 24, 2026</a:t>
+              <a:t>April 25, 2026</a:t>
             </a:fld>
             <a:r>
               <a:rPr lang="en-US" noProof="0"/>
@@ -2120,7 +2225,7 @@
           <a:graphicData uri="http://schemas.openxmlformats.org/presentationml/2006/ole">
             <mc:AlternateContent xmlns:mc="http://schemas.openxmlformats.org/markup-compatibility/2006">
               <mc:Choice xmlns:v="urn:schemas-microsoft-com:vml" Requires="v">
-                <p:oleObj spid="_x0000_s12292" name="think-cell Slide" r:id="rId4" imgW="347" imgH="348" progId="TCLayout.ActiveDocument.1">
+                <p:oleObj spid="_x0000_s12293" name="think-cell Slide" r:id="rId4" imgW="347" imgH="348" progId="TCLayout.ActiveDocument.1">
                   <p:embed/>
                 </p:oleObj>
               </mc:Choice>
@@ -2564,7 +2669,7 @@
           <a:p>
             <a:fld id="{8C17F70C-C6B6-4530-AB78-56D1DECC7D69}" type="datetime4">
               <a:rPr lang="en-US" noProof="0" smtClean="0"/>
-              <a:t>April 24, 2026</a:t>
+              <a:t>April 25, 2026</a:t>
             </a:fld>
             <a:r>
               <a:rPr lang="en-US" noProof="0"/>
@@ -2779,7 +2884,7 @@
           <a:graphicData uri="http://schemas.openxmlformats.org/presentationml/2006/ole">
             <mc:AlternateContent xmlns:mc="http://schemas.openxmlformats.org/markup-compatibility/2006">
               <mc:Choice xmlns:v="urn:schemas-microsoft-com:vml" Requires="v">
-                <p:oleObj spid="_x0000_s13316" name="think-cell Slide" r:id="rId5" imgW="347" imgH="348" progId="TCLayout.ActiveDocument.1">
+                <p:oleObj spid="_x0000_s13317" name="think-cell Slide" r:id="rId5" imgW="347" imgH="348" progId="TCLayout.ActiveDocument.1">
                   <p:embed/>
                 </p:oleObj>
               </mc:Choice>
@@ -3886,7 +3991,7 @@
           <a:graphicData uri="http://schemas.openxmlformats.org/presentationml/2006/ole">
             <mc:AlternateContent xmlns:mc="http://schemas.openxmlformats.org/markup-compatibility/2006">
               <mc:Choice xmlns:v="urn:schemas-microsoft-com:vml" Requires="v">
-                <p:oleObj spid="_x0000_s3076" name="think-cell Slide" r:id="rId4" imgW="347" imgH="348" progId="TCLayout.ActiveDocument.1">
+                <p:oleObj spid="_x0000_s3077" name="think-cell Slide" r:id="rId4" imgW="347" imgH="348" progId="TCLayout.ActiveDocument.1">
                   <p:embed/>
                 </p:oleObj>
               </mc:Choice>
@@ -4293,7 +4398,7 @@
           <a:graphicData uri="http://schemas.openxmlformats.org/presentationml/2006/ole">
             <mc:AlternateContent xmlns:mc="http://schemas.openxmlformats.org/markup-compatibility/2006">
               <mc:Choice xmlns:v="urn:schemas-microsoft-com:vml" Requires="v">
-                <p:oleObj spid="_x0000_s4100" name="think-cell Slide" r:id="rId5" imgW="347" imgH="348" progId="TCLayout.ActiveDocument.1">
+                <p:oleObj spid="_x0000_s4101" name="think-cell Slide" r:id="rId5" imgW="347" imgH="348" progId="TCLayout.ActiveDocument.1">
                   <p:embed/>
                 </p:oleObj>
               </mc:Choice>
@@ -4668,7 +4773,7 @@
           <a:graphicData uri="http://schemas.openxmlformats.org/presentationml/2006/ole">
             <mc:AlternateContent xmlns:mc="http://schemas.openxmlformats.org/markup-compatibility/2006">
               <mc:Choice xmlns:v="urn:schemas-microsoft-com:vml" Requires="v">
-                <p:oleObj spid="_x0000_s5124" name="think-cell Slide" r:id="rId5" imgW="347" imgH="348" progId="TCLayout.ActiveDocument.1">
+                <p:oleObj spid="_x0000_s5125" name="think-cell Slide" r:id="rId5" imgW="347" imgH="348" progId="TCLayout.ActiveDocument.1">
                   <p:embed/>
                 </p:oleObj>
               </mc:Choice>
@@ -4850,7 +4955,7 @@
           <a:p>
             <a:fld id="{063E3031-988C-4972-B278-DE76693A4087}" type="datetime4">
               <a:rPr lang="en-US" noProof="0" smtClean="0"/>
-              <a:t>April 24, 2026</a:t>
+              <a:t>April 25, 2026</a:t>
             </a:fld>
             <a:r>
               <a:rPr lang="en-US" noProof="0"/>
@@ -5296,7 +5401,7 @@
           <a:graphicData uri="http://schemas.openxmlformats.org/presentationml/2006/ole">
             <mc:AlternateContent xmlns:mc="http://schemas.openxmlformats.org/markup-compatibility/2006">
               <mc:Choice xmlns:v="urn:schemas-microsoft-com:vml" Requires="v">
-                <p:oleObj spid="_x0000_s6148" name="think-cell Slide" r:id="rId5" imgW="347" imgH="348" progId="TCLayout.ActiveDocument.1">
+                <p:oleObj spid="_x0000_s6149" name="think-cell Slide" r:id="rId5" imgW="347" imgH="348" progId="TCLayout.ActiveDocument.1">
                   <p:embed/>
                 </p:oleObj>
               </mc:Choice>
@@ -5563,7 +5668,7 @@
           <a:p>
             <a:fld id="{BCC64D4F-4A56-4BEC-8D01-3EDB84399994}" type="datetime4">
               <a:rPr lang="en-US" noProof="0" smtClean="0"/>
-              <a:t>April 24, 2026</a:t>
+              <a:t>April 25, 2026</a:t>
             </a:fld>
             <a:r>
               <a:rPr lang="en-US" noProof="0"/>
@@ -5923,7 +6028,7 @@
           <a:graphicData uri="http://schemas.openxmlformats.org/presentationml/2006/ole">
             <mc:AlternateContent xmlns:mc="http://schemas.openxmlformats.org/markup-compatibility/2006">
               <mc:Choice xmlns:v="urn:schemas-microsoft-com:vml" Requires="v">
-                <p:oleObj spid="_x0000_s7172" name="think-cell Slide" r:id="rId5" imgW="347" imgH="348" progId="TCLayout.ActiveDocument.1">
+                <p:oleObj spid="_x0000_s7173" name="think-cell Slide" r:id="rId5" imgW="347" imgH="348" progId="TCLayout.ActiveDocument.1">
                   <p:embed/>
                 </p:oleObj>
               </mc:Choice>
@@ -6190,7 +6295,7 @@
           <a:p>
             <a:fld id="{9B81C605-1CCC-44D5-9FA0-E9A30EE6768C}" type="datetime4">
               <a:rPr lang="en-US" noProof="0" smtClean="0"/>
-              <a:t>April 24, 2026</a:t>
+              <a:t>April 25, 2026</a:t>
             </a:fld>
             <a:r>
               <a:rPr lang="en-US" noProof="0"/>
@@ -6518,7 +6623,7 @@
           <a:graphicData uri="http://schemas.openxmlformats.org/presentationml/2006/ole">
             <mc:AlternateContent xmlns:mc="http://schemas.openxmlformats.org/markup-compatibility/2006">
               <mc:Choice xmlns:v="urn:schemas-microsoft-com:vml" Requires="v">
-                <p:oleObj spid="_x0000_s8196" name="think-cell Slide" r:id="rId4" imgW="347" imgH="348" progId="TCLayout.ActiveDocument.1">
+                <p:oleObj spid="_x0000_s8197" name="think-cell Slide" r:id="rId4" imgW="347" imgH="348" progId="TCLayout.ActiveDocument.1">
                   <p:embed/>
                 </p:oleObj>
               </mc:Choice>
@@ -7075,7 +7180,7 @@
           <a:p>
             <a:fld id="{BCDA6306-39C6-4AAA-BD10-2DD529978832}" type="datetime4">
               <a:rPr lang="en-US" noProof="0" smtClean="0"/>
-              <a:t>April 24, 2026</a:t>
+              <a:t>April 25, 2026</a:t>
             </a:fld>
             <a:r>
               <a:rPr lang="en-US" noProof="0"/>
@@ -7258,7 +7363,7 @@
           <a:graphicData uri="http://schemas.openxmlformats.org/presentationml/2006/ole">
             <mc:AlternateContent xmlns:mc="http://schemas.openxmlformats.org/markup-compatibility/2006">
               <mc:Choice xmlns:v="urn:schemas-microsoft-com:vml" Requires="v">
-                <p:oleObj spid="_x0000_s9220" name="think-cell Slide" r:id="rId4" imgW="347" imgH="348" progId="TCLayout.ActiveDocument.1">
+                <p:oleObj spid="_x0000_s9221" name="think-cell Slide" r:id="rId4" imgW="347" imgH="348" progId="TCLayout.ActiveDocument.1">
                   <p:embed/>
                 </p:oleObj>
               </mc:Choice>
@@ -7752,7 +7857,7 @@
           <a:p>
             <a:fld id="{57CF8E12-9512-4571-B994-799B954839DC}" type="datetime4">
               <a:rPr lang="en-US" noProof="0" smtClean="0"/>
-              <a:t>April 24, 2026</a:t>
+              <a:t>April 25, 2026</a:t>
             </a:fld>
             <a:r>
               <a:rPr lang="en-US" noProof="0"/>
@@ -7919,7 +8024,7 @@
           <a:graphicData uri="http://schemas.openxmlformats.org/presentationml/2006/ole">
             <mc:AlternateContent xmlns:mc="http://schemas.openxmlformats.org/markup-compatibility/2006">
               <mc:Choice xmlns:v="urn:schemas-microsoft-com:vml" Requires="v">
-                <p:oleObj spid="_x0000_s10244" name="think-cell Slide" r:id="rId4" imgW="347" imgH="348" progId="TCLayout.ActiveDocument.1">
+                <p:oleObj spid="_x0000_s10245" name="think-cell Slide" r:id="rId4" imgW="347" imgH="348" progId="TCLayout.ActiveDocument.1">
                   <p:embed/>
                 </p:oleObj>
               </mc:Choice>
@@ -8240,7 +8345,7 @@
           <a:p>
             <a:fld id="{8EDEEBE2-F7EE-4B55-9F2B-99F5E25A2148}" type="datetime4">
               <a:rPr lang="en-US" noProof="0" smtClean="0"/>
-              <a:t>April 24, 2026</a:t>
+              <a:t>April 25, 2026</a:t>
             </a:fld>
             <a:r>
               <a:rPr lang="en-US" noProof="0"/>
@@ -8532,7 +8637,7 @@
           <a:graphicData uri="http://schemas.openxmlformats.org/presentationml/2006/ole">
             <mc:AlternateContent xmlns:mc="http://schemas.openxmlformats.org/markup-compatibility/2006">
               <mc:Choice xmlns:v="urn:schemas-microsoft-com:vml" Requires="v">
-                <p:oleObj spid="_x0000_s1028" name="think-cell Slide" r:id="rId16" imgW="347" imgH="348" progId="TCLayout.ActiveDocument.1">
+                <p:oleObj spid="_x0000_s1029" name="think-cell Slide" r:id="rId16" imgW="347" imgH="348" progId="TCLayout.ActiveDocument.1">
                   <p:embed/>
                 </p:oleObj>
               </mc:Choice>
@@ -8830,7 +8935,7 @@
           <a:p>
             <a:fld id="{E425F5DC-A670-472C-8764-DD4E51A3863B}" type="datetime4">
               <a:rPr lang="en-US" noProof="0" smtClean="0"/>
-              <a:t>April 24, 2026</a:t>
+              <a:t>April 25, 2026</a:t>
             </a:fld>
             <a:r>
               <a:rPr lang="en-US" noProof="0"/>
@@ -10242,7 +10347,7 @@
         <p:spPr>
           <a:xfrm>
             <a:off x="11475720" y="6455664"/>
-            <a:ext cx="457200" cy="164592"/>
+            <a:ext cx="457200" cy="149913"/>
           </a:xfrm>
           <a:prstGeom prst="rect">
             <a:avLst/>
@@ -10255,15 +10360,26 @@
           </a:bodyPr>
           <a:lstStyle/>
           <a:p>
-            <a:r>
-              <a:rPr sz="900">
+            <a:pPr algn="l">
+              <a:lnSpc>
+                <a:spcPct val="115000"/>
+              </a:lnSpc>
+            </a:pPr>
+            <a:r>
+              <a:rPr lang="de-DE" sz="900" dirty="0">
                 <a:solidFill>
-                  <a:srgbClr val="666666"/>
+                  <a:srgbClr val="465462"/>
                 </a:solidFill>
                 <a:latin typeface="GFT Corporate Light"/>
               </a:rPr>
               <a:t>10</a:t>
             </a:r>
+            <a:endParaRPr sz="900" b="0" dirty="0">
+              <a:solidFill>
+                <a:srgbClr val="465462"/>
+              </a:solidFill>
+              <a:latin typeface="GFT Corporate Light"/>
+            </a:endParaRPr>
           </a:p>
         </p:txBody>
       </p:sp>
@@ -10289,8 +10405,19 @@
           </a:bodyPr>
           <a:lstStyle/>
           <a:p>
-            <a:r>
-              <a:t>Live-Demo: die Demo-App in Kürze</a:t>
+            <a:pPr algn="l">
+              <a:lnSpc>
+                <a:spcPct val="105000"/>
+              </a:lnSpc>
+            </a:pPr>
+            <a:r>
+              <a:rPr sz="3000" b="1">
+                <a:solidFill>
+                  <a:srgbClr val="001326"/>
+                </a:solidFill>
+                <a:latin typeface="GFT Corporate SemiBold"/>
+              </a:rPr>
+              <a:t>Live-Demo: worauf wir gleich achten</a:t>
             </a:r>
           </a:p>
         </p:txBody>
@@ -10317,8 +10444,14 @@
           </a:bodyPr>
           <a:lstStyle/>
           <a:p>
-            <a:r>
-              <a:t>Eine Anwendung, zwei Frontends und dieselben Backend-Services.</a:t>
+            <a:pPr algn="l">
+              <a:lnSpc>
+                <a:spcPct val="115000"/>
+              </a:lnSpc>
+            </a:pPr>
+            <a:r>
+              <a:rPr sz="1500"/>
+              <a:t>Dieselbe Anwendung — einmal mit und einmal ohne BFF.</a:t>
             </a:r>
           </a:p>
         </p:txBody>
@@ -10390,8 +10523,19 @@
           </a:bodyPr>
           <a:lstStyle/>
           <a:p>
-            <a:r>
-              <a:t>Demo-App</a:t>
+            <a:pPr algn="l">
+              <a:lnSpc>
+                <a:spcPct val="115000"/>
+              </a:lnSpc>
+            </a:pPr>
+            <a:r>
+              <a:rPr sz="1250" b="0">
+                <a:solidFill>
+                  <a:srgbClr val="5199E2"/>
+                </a:solidFill>
+                <a:latin typeface="GFT Corporate Light"/>
+              </a:rPr>
+              <a:t>Demo-Setup</a:t>
             </a:r>
           </a:p>
         </p:txBody>
@@ -10418,13 +10562,20 @@
           </a:bodyPr>
           <a:lstStyle/>
           <a:p>
-            <a:r>
-              <a:t>Zwei Angular-Frontends:</a:t>
-            </a:r>
-          </a:p>
-          <a:p>
-            <a:r>
-              <a:t>No-BFF und With BFF</a:t>
+            <a:pPr algn="l">
+              <a:lnSpc>
+                <a:spcPct val="115000"/>
+              </a:lnSpc>
+            </a:pPr>
+            <a:r>
+              <a:rPr sz="1250"/>
+              <a:t>Zwei Frontends,</a:t>
+            </a:r>
+          </a:p>
+          <a:p>
+            <a:r>
+              <a:rPr sz="1250"/>
+              <a:t>eine Service-Landschaft.</a:t>
             </a:r>
           </a:p>
         </p:txBody>
@@ -10451,8 +10602,19 @@
           </a:bodyPr>
           <a:lstStyle/>
           <a:p>
-            <a:r>
-              <a:t>Backend-Landschaft</a:t>
+            <a:pPr algn="l">
+              <a:lnSpc>
+                <a:spcPct val="115000"/>
+              </a:lnSpc>
+            </a:pPr>
+            <a:r>
+              <a:rPr sz="1250" b="1">
+                <a:solidFill>
+                  <a:srgbClr val="5199E2"/>
+                </a:solidFill>
+                <a:latin typeface="GFT Corporate SemiBold"/>
+              </a:rPr>
+              <a:t>Read-Szenario</a:t>
             </a:r>
           </a:p>
         </p:txBody>
@@ -10479,13 +10641,20 @@
           </a:bodyPr>
           <a:lstStyle/>
           <a:p>
-            <a:r>
-              <a:t>Keycloak, BFF sowie</a:t>
-            </a:r>
-          </a:p>
-          <a:p>
-            <a:r>
-              <a:t>User-, Notification- und Activity-Service</a:t>
+            <a:pPr algn="l">
+              <a:lnSpc>
+                <a:spcPct val="130000"/>
+              </a:lnSpc>
+            </a:pPr>
+            <a:r>
+              <a:rPr sz="1200"/>
+              <a:t>Aggregation über</a:t>
+            </a:r>
+          </a:p>
+          <a:p>
+            <a:r>
+              <a:rPr sz="1200"/>
+              <a:t>mehrere Services</a:t>
             </a:r>
           </a:p>
         </p:txBody>
@@ -10512,8 +10681,19 @@
           </a:bodyPr>
           <a:lstStyle/>
           <a:p>
-            <a:r>
-              <a:t>Gezeigte Flows</a:t>
+            <a:pPr algn="l">
+              <a:lnSpc>
+                <a:spcPct val="115000"/>
+              </a:lnSpc>
+            </a:pPr>
+            <a:r>
+              <a:rPr sz="1250" b="1">
+                <a:solidFill>
+                  <a:srgbClr val="5199E2"/>
+                </a:solidFill>
+                <a:latin typeface="GFT Corporate SemiBold"/>
+              </a:rPr>
+              <a:t>Write-Szenario</a:t>
             </a:r>
           </a:p>
         </p:txBody>
@@ -10540,13 +10720,20 @@
           </a:bodyPr>
           <a:lstStyle/>
           <a:p>
-            <a:r>
-              <a:t>Read mit Aggregation</a:t>
-            </a:r>
-          </a:p>
-          <a:p>
-            <a:r>
-              <a:t>und verteilter Write als Saga</a:t>
+            <a:pPr algn="l">
+              <a:lnSpc>
+                <a:spcPct val="130000"/>
+              </a:lnSpc>
+            </a:pPr>
+            <a:r>
+              <a:rPr sz="1200"/>
+              <a:t>Verteilter Write</a:t>
+            </a:r>
+          </a:p>
+          <a:p>
+            <a:r>
+              <a:rPr sz="1200"/>
+              <a:t>als Saga mit Kompensation</a:t>
             </a:r>
           </a:p>
         </p:txBody>
@@ -10560,7 +10747,7 @@
         <p:spPr>
           <a:xfrm>
             <a:off x="4599431" y="2514600"/>
-            <a:ext cx="7150608" cy="365760"/>
+            <a:ext cx="7350608" cy="365760"/>
           </a:xfrm>
           <a:prstGeom prst="rect">
             <a:avLst/>
@@ -10652,7 +10839,7 @@
         <p:spPr>
           <a:xfrm>
             <a:off x="5056631" y="2971800"/>
-            <a:ext cx="6693408" cy="274320"/>
+            <a:ext cx="6893408" cy="274320"/>
           </a:xfrm>
           <a:prstGeom prst="rect">
             <a:avLst/>
@@ -10665,8 +10852,14 @@
           </a:bodyPr>
           <a:lstStyle/>
           <a:p>
-            <a:r>
-              <a:t>Netzwerk &amp; Aufrufe</a:t>
+            <a:pPr algn="l">
+              <a:lnSpc>
+                <a:spcPct val="115000"/>
+              </a:lnSpc>
+            </a:pPr>
+            <a:r>
+              <a:rPr sz="1250"/>
+              <a:t>Sichtbare Aufrufe im Netzwerk</a:t>
             </a:r>
           </a:p>
         </p:txBody>
@@ -10680,7 +10873,7 @@
         <p:spPr>
           <a:xfrm>
             <a:off x="5056631" y="3227832"/>
-            <a:ext cx="6693408" cy="320040"/>
+            <a:ext cx="6893408" cy="320040"/>
           </a:xfrm>
           <a:prstGeom prst="rect">
             <a:avLst/>
@@ -10693,13 +10886,20 @@
           </a:bodyPr>
           <a:lstStyle/>
           <a:p>
-            <a:r>
-              <a:t>No-BFF: mehrere Browser-Calls.</a:t>
-            </a:r>
-          </a:p>
-          <a:p>
-            <a:r>
-              <a:t>BFF: ein zentraler Aufruf.</a:t>
+            <a:pPr algn="l">
+              <a:lnSpc>
+                <a:spcPct val="125000"/>
+              </a:lnSpc>
+            </a:pPr>
+            <a:r>
+              <a:rPr sz="1150"/>
+              <a:t>No-BFF: viele Browser-Calls.</a:t>
+            </a:r>
+          </a:p>
+          <a:p>
+            <a:r>
+              <a:rPr sz="1150"/>
+              <a:t>BFF: ein zentraler Call.</a:t>
             </a:r>
           </a:p>
         </p:txBody>
@@ -10712,7 +10912,7 @@
         </p:nvSpPr>
         <p:spPr>
           <a:xfrm>
-            <a:off x="4599431" y="3611879"/>
+            <a:off x="4599431" y="3671879"/>
             <a:ext cx="320040" cy="320040"/>
           </a:xfrm>
           <a:prstGeom prst="ellipse">
@@ -10765,8 +10965,8 @@
         </p:nvSpPr>
         <p:spPr>
           <a:xfrm>
-            <a:off x="5056631" y="3566160"/>
-            <a:ext cx="6693408" cy="274320"/>
+            <a:off x="5056631" y="3626160"/>
+            <a:ext cx="6893408" cy="274320"/>
           </a:xfrm>
           <a:prstGeom prst="rect">
             <a:avLst/>
@@ -10779,8 +10979,14 @@
           </a:bodyPr>
           <a:lstStyle/>
           <a:p>
-            <a:r>
-              <a:t>Authentifizierung</a:t>
+            <a:pPr algn="l">
+              <a:lnSpc>
+                <a:spcPct val="115000"/>
+              </a:lnSpc>
+            </a:pPr>
+            <a:r>
+              <a:rPr sz="1250"/>
+              <a:t>Token im Frontend</a:t>
             </a:r>
           </a:p>
         </p:txBody>
@@ -10793,8 +10999,8 @@
         </p:nvSpPr>
         <p:spPr>
           <a:xfrm>
-            <a:off x="5056631" y="3822191"/>
-            <a:ext cx="6693408" cy="320040"/>
+            <a:off x="5056631" y="3882191"/>
+            <a:ext cx="6893408" cy="320040"/>
           </a:xfrm>
           <a:prstGeom prst="rect">
             <a:avLst/>
@@ -10807,13 +11013,20 @@
           </a:bodyPr>
           <a:lstStyle/>
           <a:p>
-            <a:r>
-              <a:t>No-BFF: Token im Browser.</a:t>
-            </a:r>
-          </a:p>
-          <a:p>
-            <a:r>
-              <a:t>BFF: Session-Cookie, tokenfreier Client.</a:t>
+            <a:pPr algn="l">
+              <a:lnSpc>
+                <a:spcPct val="125000"/>
+              </a:lnSpc>
+            </a:pPr>
+            <a:r>
+              <a:rPr sz="1150"/>
+              <a:t>No-BFF: Token sichtbar.</a:t>
+            </a:r>
+          </a:p>
+          <a:p>
+            <a:r>
+              <a:rPr sz="1150"/>
+              <a:t>BFF: tokenfreier Client.</a:t>
             </a:r>
           </a:p>
         </p:txBody>
@@ -10826,7 +11039,7 @@
         </p:nvSpPr>
         <p:spPr>
           <a:xfrm>
-            <a:off x="4599431" y="4206240"/>
+            <a:off x="4599431" y="4326240"/>
             <a:ext cx="320040" cy="320040"/>
           </a:xfrm>
           <a:prstGeom prst="ellipse">
@@ -10879,8 +11092,8 @@
         </p:nvSpPr>
         <p:spPr>
           <a:xfrm>
-            <a:off x="5056631" y="4160520"/>
-            <a:ext cx="6693408" cy="274320"/>
+            <a:off x="5056631" y="4280520"/>
+            <a:ext cx="6893408" cy="274320"/>
           </a:xfrm>
           <a:prstGeom prst="rect">
             <a:avLst/>
@@ -10893,8 +11106,14 @@
           </a:bodyPr>
           <a:lstStyle/>
           <a:p>
-            <a:r>
-              <a:t>TypeScript-Komplexität</a:t>
+            <a:pPr algn="l">
+              <a:lnSpc>
+                <a:spcPct val="115000"/>
+              </a:lnSpc>
+            </a:pPr>
+            <a:r>
+              <a:rPr sz="1250"/>
+              <a:t>TypeScript-Integrationslogik</a:t>
             </a:r>
           </a:p>
         </p:txBody>
@@ -10907,8 +11126,8 @@
         </p:nvSpPr>
         <p:spPr>
           <a:xfrm>
-            <a:off x="5056631" y="4416552"/>
-            <a:ext cx="6693408" cy="320040"/>
+            <a:off x="5056631" y="4536552"/>
+            <a:ext cx="6893408" cy="320040"/>
           </a:xfrm>
           <a:prstGeom prst="rect">
             <a:avLst/>
@@ -10921,13 +11140,20 @@
           </a:bodyPr>
           <a:lstStyle/>
           <a:p>
-            <a:r>
-              <a:t>No-BFF: Aggregation, Orchestrierung</a:t>
-            </a:r>
-          </a:p>
-          <a:p>
-            <a:r>
-              <a:t>und Kompensation im Client.</a:t>
+            <a:pPr algn="l">
+              <a:lnSpc>
+                <a:spcPct val="125000"/>
+              </a:lnSpc>
+            </a:pPr>
+            <a:r>
+              <a:rPr sz="1150"/>
+              <a:t>No-BFF: Aggregation, Orchestrierung, Kompensation im Client.</a:t>
+            </a:r>
+          </a:p>
+          <a:p>
+            <a:r>
+              <a:rPr sz="1150"/>
+              <a:t>BFF: UI bleibt schlank.</a:t>
             </a:r>
           </a:p>
         </p:txBody>
@@ -10940,7 +11166,7 @@
         </p:nvSpPr>
         <p:spPr>
           <a:xfrm>
-            <a:off x="4599431" y="4800600"/>
+            <a:off x="4599431" y="4980600"/>
             <a:ext cx="320040" cy="320040"/>
           </a:xfrm>
           <a:prstGeom prst="ellipse">
@@ -10993,8 +11219,8 @@
         </p:nvSpPr>
         <p:spPr>
           <a:xfrm>
-            <a:off x="5056631" y="4754880"/>
-            <a:ext cx="6693408" cy="274320"/>
+            <a:off x="5056631" y="4934880"/>
+            <a:ext cx="6893408" cy="274320"/>
           </a:xfrm>
           <a:prstGeom prst="rect">
             <a:avLst/>
@@ -11007,8 +11233,14 @@
           </a:bodyPr>
           <a:lstStyle/>
           <a:p>
-            <a:r>
-              <a:t>Write-Flow</a:t>
+            <a:pPr algn="l">
+              <a:lnSpc>
+                <a:spcPct val="115000"/>
+              </a:lnSpc>
+            </a:pPr>
+            <a:r>
+              <a:rPr sz="1250"/>
+              <a:t>Fehlerfall im Write</a:t>
             </a:r>
           </a:p>
         </p:txBody>
@@ -11021,8 +11253,8 @@
         </p:nvSpPr>
         <p:spPr>
           <a:xfrm>
-            <a:off x="5056631" y="5010912"/>
-            <a:ext cx="6693408" cy="320040"/>
+            <a:off x="5056631" y="5190912"/>
+            <a:ext cx="6893408" cy="320040"/>
           </a:xfrm>
           <a:prstGeom prst="rect">
             <a:avLst/>
@@ -11035,13 +11267,20 @@
           </a:bodyPr>
           <a:lstStyle/>
           <a:p>
-            <a:r>
+            <a:pPr algn="l">
+              <a:lnSpc>
+                <a:spcPct val="125000"/>
+              </a:lnSpc>
+            </a:pPr>
+            <a:r>
+              <a:rPr sz="1150"/>
               <a:t>No-BFF: clientseitige Saga.</a:t>
             </a:r>
           </a:p>
           <a:p>
             <a:r>
-              <a:t>BFF: serverseitige BFF-Orchestrierung.</a:t>
+              <a:rPr sz="1150"/>
+              <a:t>BFF: serverseitige Orchestrierung.</a:t>
             </a:r>
           </a:p>
         </p:txBody>
@@ -11054,7 +11293,7 @@
         </p:nvSpPr>
         <p:spPr>
           <a:xfrm>
-            <a:off x="4599431" y="5394960"/>
+            <a:off x="4599431" y="5634960"/>
             <a:ext cx="320040" cy="320040"/>
           </a:xfrm>
           <a:prstGeom prst="ellipse">
@@ -11107,8 +11346,8 @@
         </p:nvSpPr>
         <p:spPr>
           <a:xfrm>
-            <a:off x="5056631" y="5349240"/>
-            <a:ext cx="6693408" cy="274320"/>
+            <a:off x="5056631" y="5589240"/>
+            <a:ext cx="6893408" cy="274320"/>
           </a:xfrm>
           <a:prstGeom prst="rect">
             <a:avLst/>
@@ -11121,7 +11360,13 @@
           </a:bodyPr>
           <a:lstStyle/>
           <a:p>
-            <a:r>
+            <a:pPr algn="l">
+              <a:lnSpc>
+                <a:spcPct val="115000"/>
+              </a:lnSpc>
+            </a:pPr>
+            <a:r>
+              <a:rPr sz="1250"/>
               <a:t>Änderungswirkung</a:t>
             </a:r>
           </a:p>
@@ -11135,8 +11380,8 @@
         </p:nvSpPr>
         <p:spPr>
           <a:xfrm>
-            <a:off x="5056631" y="5605272"/>
-            <a:ext cx="6693408" cy="320040"/>
+            <a:off x="5056631" y="5845272"/>
+            <a:ext cx="6893408" cy="320040"/>
           </a:xfrm>
           <a:prstGeom prst="rect">
             <a:avLst/>
@@ -11149,14 +11394,145 @@
           </a:bodyPr>
           <a:lstStyle/>
           <a:p>
-            <a:r>
+            <a:pPr algn="l">
+              <a:lnSpc>
+                <a:spcPct val="125000"/>
+              </a:lnSpc>
+            </a:pPr>
+            <a:r>
+              <a:rPr sz="1150"/>
               <a:t>No-BFF: Frontend muss oft mit.</a:t>
             </a:r>
           </a:p>
           <a:p>
             <a:r>
-              <a:t>BFF: vieles bleibt im Backend.</a:t>
-            </a:r>
+              <a:rPr sz="1150"/>
+              <a:t>BFF: vieles bleibt serverseitig.</a:t>
+            </a:r>
+          </a:p>
+        </p:txBody>
+      </p:sp>
+      <p:sp>
+        <p:nvSpPr>
+          <p:cNvPr id="100" name="Separator 1"/>
+          <p:cNvSpPr/>
+          <p:nvPr/>
+        </p:nvSpPr>
+        <p:spPr>
+          <a:xfrm>
+            <a:off x="4599431" y="3605114"/>
+            <a:ext cx="7350608" cy="9525"/>
+          </a:xfrm>
+          <a:prstGeom prst="rect">
+            <a:avLst/>
+          </a:prstGeom>
+          <a:solidFill>
+            <a:srgbClr val="C5CCD4"/>
+          </a:solidFill>
+          <a:ln>
+            <a:noFill/>
+          </a:ln>
+          <a:effectLst/>
+        </p:spPr>
+        <p:txBody>
+          <a:bodyPr rtlCol="0" anchor="ctr"/>
+          <a:lstStyle/>
+          <a:p>
+            <a:pPr algn="ctr"/>
+            <a:endParaRPr/>
+          </a:p>
+        </p:txBody>
+      </p:sp>
+      <p:sp>
+        <p:nvSpPr>
+          <p:cNvPr id="101" name="Separator 2"/>
+          <p:cNvSpPr/>
+          <p:nvPr/>
+        </p:nvSpPr>
+        <p:spPr>
+          <a:xfrm>
+            <a:off x="4599431" y="4259474"/>
+            <a:ext cx="7350608" cy="9525"/>
+          </a:xfrm>
+          <a:prstGeom prst="rect">
+            <a:avLst/>
+          </a:prstGeom>
+          <a:solidFill>
+            <a:srgbClr val="C5CCD4"/>
+          </a:solidFill>
+          <a:ln>
+            <a:noFill/>
+          </a:ln>
+          <a:effectLst/>
+        </p:spPr>
+        <p:txBody>
+          <a:bodyPr rtlCol="0" anchor="ctr"/>
+          <a:lstStyle/>
+          <a:p>
+            <a:pPr algn="ctr"/>
+            <a:endParaRPr/>
+          </a:p>
+        </p:txBody>
+      </p:sp>
+      <p:sp>
+        <p:nvSpPr>
+          <p:cNvPr id="102" name="Separator 3"/>
+          <p:cNvSpPr/>
+          <p:nvPr/>
+        </p:nvSpPr>
+        <p:spPr>
+          <a:xfrm>
+            <a:off x="4599431" y="4913834"/>
+            <a:ext cx="7350608" cy="9525"/>
+          </a:xfrm>
+          <a:prstGeom prst="rect">
+            <a:avLst/>
+          </a:prstGeom>
+          <a:solidFill>
+            <a:srgbClr val="C5CCD4"/>
+          </a:solidFill>
+          <a:ln>
+            <a:noFill/>
+          </a:ln>
+          <a:effectLst/>
+        </p:spPr>
+        <p:txBody>
+          <a:bodyPr rtlCol="0" anchor="ctr"/>
+          <a:lstStyle/>
+          <a:p>
+            <a:pPr algn="ctr"/>
+            <a:endParaRPr/>
+          </a:p>
+        </p:txBody>
+      </p:sp>
+      <p:sp>
+        <p:nvSpPr>
+          <p:cNvPr id="103" name="Separator 4"/>
+          <p:cNvSpPr/>
+          <p:nvPr/>
+        </p:nvSpPr>
+        <p:spPr>
+          <a:xfrm>
+            <a:off x="4599431" y="5568194"/>
+            <a:ext cx="7350608" cy="9525"/>
+          </a:xfrm>
+          <a:prstGeom prst="rect">
+            <a:avLst/>
+          </a:prstGeom>
+          <a:solidFill>
+            <a:srgbClr val="C5CCD4"/>
+          </a:solidFill>
+          <a:ln>
+            <a:noFill/>
+          </a:ln>
+          <a:effectLst/>
+        </p:spPr>
+        <p:txBody>
+          <a:bodyPr rtlCol="0" anchor="ctr"/>
+          <a:lstStyle/>
+          <a:p>
+            <a:pPr algn="ctr"/>
+            <a:endParaRPr/>
           </a:p>
         </p:txBody>
       </p:sp>
@@ -22664,18 +23040,18 @@
 </file>
 
 <file path=customXml/item1.xml><?xml version="1.0" encoding="utf-8"?>
+<p:properties xmlns:p="http://schemas.microsoft.com/office/2006/metadata/properties" xmlns:xsi="http://www.w3.org/2001/XMLSchema-instance" xmlns:pc="http://schemas.microsoft.com/office/infopath/2007/PartnerControls">
+  <documentManagement/>
+</p:properties>
+</file>
+
+<file path=customXml/item2.xml><?xml version="1.0" encoding="utf-8"?>
 <?mso-contentType ?>
 <FormTemplates xmlns="http://schemas.microsoft.com/sharepoint/v3/contenttype/forms">
   <Display>DocumentLibraryForm</Display>
   <Edit>DocumentLibraryForm</Edit>
   <New>DocumentLibraryForm</New>
 </FormTemplates>
-</file>
-
-<file path=customXml/item2.xml><?xml version="1.0" encoding="utf-8"?>
-<p:properties xmlns:p="http://schemas.microsoft.com/office/2006/metadata/properties" xmlns:xsi="http://www.w3.org/2001/XMLSchema-instance" xmlns:pc="http://schemas.microsoft.com/office/infopath/2007/PartnerControls">
-  <documentManagement/>
-</p:properties>
 </file>
 
 <file path=customXml/item3.xml><?xml version="1.0" encoding="utf-8"?>
@@ -22823,25 +23199,25 @@
 </file>
 
 <file path=customXml/itemProps1.xml><?xml version="1.0" encoding="utf-8"?>
-<ds:datastoreItem xmlns:ds="http://schemas.openxmlformats.org/officeDocument/2006/customXml" ds:itemID="{DEEB635D-8776-4858-B841-43186E959E9C}">
+<ds:datastoreItem xmlns:ds="http://schemas.openxmlformats.org/officeDocument/2006/customXml" ds:itemID="{D42AB8F2-D9EA-4EDB-92E9-A1D6D677FB83}">
   <ds:schemaRefs>
-    <ds:schemaRef ds:uri="http://schemas.microsoft.com/sharepoint/v3/contenttype/forms"/>
+    <ds:schemaRef ds:uri="http://purl.org/dc/dcmitype/"/>
+    <ds:schemaRef ds:uri="http://schemas.openxmlformats.org/package/2006/metadata/core-properties"/>
+    <ds:schemaRef ds:uri="http://purl.org/dc/terms/"/>
+    <ds:schemaRef ds:uri="http://schemas.microsoft.com/office/2006/documentManagement/types"/>
+    <ds:schemaRef ds:uri="http://schemas.microsoft.com/office/2006/metadata/properties"/>
+    <ds:schemaRef ds:uri="6f58215a-c5da-4c8d-9efa-75a6a7d28cbe"/>
+    <ds:schemaRef ds:uri="http://www.w3.org/XML/1998/namespace"/>
+    <ds:schemaRef ds:uri="http://schemas.microsoft.com/office/infopath/2007/PartnerControls"/>
+    <ds:schemaRef ds:uri="http://purl.org/dc/elements/1.1/"/>
   </ds:schemaRefs>
 </ds:datastoreItem>
 </file>
 
 <file path=customXml/itemProps2.xml><?xml version="1.0" encoding="utf-8"?>
-<ds:datastoreItem xmlns:ds="http://schemas.openxmlformats.org/officeDocument/2006/customXml" ds:itemID="{D42AB8F2-D9EA-4EDB-92E9-A1D6D677FB83}">
+<ds:datastoreItem xmlns:ds="http://schemas.openxmlformats.org/officeDocument/2006/customXml" ds:itemID="{DEEB635D-8776-4858-B841-43186E959E9C}">
   <ds:schemaRefs>
-    <ds:schemaRef ds:uri="http://schemas.microsoft.com/office/2006/metadata/properties"/>
-    <ds:schemaRef ds:uri="http://purl.org/dc/terms/"/>
-    <ds:schemaRef ds:uri="http://purl.org/dc/elements/1.1/"/>
-    <ds:schemaRef ds:uri="http://schemas.microsoft.com/office/infopath/2007/PartnerControls"/>
-    <ds:schemaRef ds:uri="http://schemas.microsoft.com/office/2006/documentManagement/types"/>
-    <ds:schemaRef ds:uri="http://schemas.openxmlformats.org/package/2006/metadata/core-properties"/>
-    <ds:schemaRef ds:uri="6f58215a-c5da-4c8d-9efa-75a6a7d28cbe"/>
-    <ds:schemaRef ds:uri="http://www.w3.org/XML/1998/namespace"/>
-    <ds:schemaRef ds:uri="http://purl.org/dc/dcmitype/"/>
+    <ds:schemaRef ds:uri="http://schemas.microsoft.com/sharepoint/v3/contenttype/forms"/>
   </ds:schemaRefs>
 </ds:datastoreItem>
 </file>

</xml_diff>